<commit_message>
Record the fresh-clone demo rehearsal (A-09 PASS) in the report and deck
tasks.py demo-readiness on a fresh clone of 9b233e0: 112 PASS, 0 FAIL.
Report and slides regenerated from facts.json; only A-10 (real user tests)
stays PENDING.

Co-Authored-By: Claude Opus 5.5 <noreply@anthropic.com>
</commit_message>
<xml_diff>
--- a/docs/slides/urban_traffic_twin.pptx
+++ b/docs/slides/urban_traffic_twin.pptx
@@ -2054,7 +2054,7 @@
           <a:lstStyle/>
           <a:p>
             <a:r>
-              <a:t>Each lamp is generated from its evidence file. PENDING means the evidence does not exist yet. Still pending: A-09 (demo without touching the code): no fresh-clone readiness rehearsal yet (python tasks.py demo-readiness on the release commit); A-10 (3 to 5 real users): no session yet; 3 to 5 real sessions needed (spec 12.2). The presenter's own rehearsal of the demo is not recorded yet. A-06 passes when the comparison is valid and shown, whatever its direction; A-10 needs three to five real users.</a:t>
+              <a:t>Each lamp is generated from its evidence file. PENDING means the evidence does not exist yet. Still pending: A-10 (3 to 5 real users): no session yet; 3 to 5 real sessions needed (spec 12.2). The presenter's own rehearsal of the demo is not recorded yet. A-06 passes when the comparison is valid and shown, whatever its direction; A-10 needs three to five real users.</a:t>
             </a:r>
           </a:p>
         </p:txBody>
@@ -8312,7 +8312,7 @@
                 </a:solidFill>
                 <a:latin typeface="Calibri"/>
               </a:rPr>
-              <a:t>Acceptance: 8 of 10 criteria met so far</a:t>
+              <a:t>Acceptance: 9 of 10 criteria met so far</a:t>
             </a:r>
           </a:p>
         </p:txBody>
@@ -9973,7 +9973,7 @@
             <a:avLst/>
           </a:prstGeom>
           <a:solidFill>
-            <a:srgbClr val="F2A900"/>
+            <a:srgbClr val="5FB8B0"/>
           </a:solidFill>
           <a:ln>
             <a:noFill/>
@@ -10063,11 +10063,11 @@
             <a:r>
               <a:rPr sz="1600" b="1" i="0">
                 <a:solidFill>
-                  <a:srgbClr val="F2A900"/>
-                </a:solidFill>
-                <a:latin typeface="Calibri"/>
-              </a:rPr>
-              <a:t>PENDING</a:t>
+                  <a:srgbClr val="5FB8B0"/>
+                </a:solidFill>
+                <a:latin typeface="Calibri"/>
+              </a:rPr>
+              <a:t>PASS</a:t>
             </a:r>
           </a:p>
         </p:txBody>
@@ -11361,7 +11361,7 @@
                 </a:solidFill>
                 <a:latin typeface="Calibri"/>
               </a:rPr>
-              <a:t>Automated: A-08 PASS · A-09 PENDING</a:t>
+              <a:t>Automated: A-08 PASS · A-09 PASS</a:t>
             </a:r>
           </a:p>
           <a:p>

</xml_diff>